<commit_message>
close the test-coverage gaps: stress suite, fuzz combinations, sugar paths
- stress.test.ts: agent-like multi-apply sessions covering every op kind
  and element type (textbox, table, chart, shape, image, connector),
  append mode, picture-placeholder fill, img.prompts happy path, XML
  escaping -- file integrity asserted after EVERY apply
- seeded-random edit combinations (reproducible LCG, 12 rounds): random
  add/fill/copy/move/rm/el/note/footer mixes must never leave a broken
  file, planner rejections must leave the deck untouched and intact
- contract: sugar (text/note/footer/move/rm) and read commands
  (tpl list/validate, schema) happy paths against the built bundle
- fixture: new PICTURE layout with picture placeholder, unique
  placeholder names per layout, passes tpl validate; golden updated

Co-Authored-By: Claude Fable 5 <noreply@anthropic.com>
</commit_message>
<xml_diff>
--- a/test/fixtures/neutral-template.pptx
+++ b/test/fixtures/neutral-template.pptx
@@ -732,7 +732,7 @@
     </p:bg>
     <p:spTree>
       <p:nvGrpSpPr>
-        <p:cNvPr id="1" name=""/>
+        <p:cNvPr id="1" name="Body 1-1"/>
         <p:cNvGrpSpPr/>
         <p:nvPr/>
       </p:nvGrpSpPr>
@@ -764,7 +764,7 @@
     </p:bg>
     <p:spTree>
       <p:nvGrpSpPr>
-        <p:cNvPr id="1" name=""/>
+        <p:cNvPr id="1" name="Body 2-1"/>
         <p:cNvGrpSpPr/>
         <p:nvPr/>
       </p:nvGrpSpPr>
@@ -778,7 +778,7 @@
       </p:grpSpPr>
       <p:sp>
         <p:nvSpPr>
-          <p:cNvPr id="2" name="Text 0"/>
+          <p:cNvPr id="2" name="Body 2-2"/>
           <p:cNvSpPr/>
           <p:nvPr>
             <p:ph idx="100" type="title" hasCustomPrompt="1"/>
@@ -821,7 +821,7 @@
       </p:sp>
       <p:sp>
         <p:nvSpPr>
-          <p:cNvPr id="3" name="Text 0"/>
+          <p:cNvPr id="3" name="Body 2-3"/>
           <p:cNvSpPr/>
           <p:nvPr>
             <p:ph idx="101" type="body" hasCustomPrompt="1"/>
@@ -880,6 +880,278 @@
         </a:solidFill>
       </p:bgPr>
     </p:bg>
+    <p:spTree>
+      <p:nvGrpSpPr>
+        <p:cNvPr id="1" name="Body 3-1"/>
+        <p:cNvGrpSpPr/>
+        <p:nvPr/>
+      </p:nvGrpSpPr>
+      <p:grpSpPr>
+        <a:xfrm>
+          <a:off x="0" y="0"/>
+          <a:ext cx="0" cy="0"/>
+          <a:chOff x="0" y="0"/>
+          <a:chExt cx="0" cy="0"/>
+        </a:xfrm>
+      </p:grpSpPr>
+      <p:sp>
+        <p:nvSpPr>
+          <p:cNvPr id="2" name="Body 3-2"/>
+          <p:cNvSpPr/>
+          <p:nvPr>
+            <p:ph idx="100" type="title" hasCustomPrompt="1"/>
+          </p:nvPr>
+        </p:nvSpPr>
+        <p:spPr>
+          <a:xfrm>
+            <a:off x="640080" y="365760"/>
+            <a:ext cx="10972800" cy="914400"/>
+          </a:xfrm>
+          <a:prstGeom prst="rect">
+            <a:avLst/>
+          </a:prstGeom>
+          <a:noFill/>
+          <a:ln/>
+        </p:spPr>
+        <p:txBody>
+          <a:bodyPr wrap="square" rtlCol="0"/>
+          <a:lstStyle>
+            <a:lvl1pPr indent="0" marL="0">
+              <a:buNone/>
+              <a:defRPr lang="en-US" dirty="0"/>
+            </a:lvl1pPr>
+          </a:lstStyle>
+          <a:p>
+            <a:pPr indent="0" marL="0">
+              <a:buNone/>
+            </a:pPr>
+            <a:r>
+              <a:rPr lang="en-US" dirty="0">
+                <a:solidFill>
+                  <a:srgbClr val="000000"/>
+                </a:solidFill>
+              </a:rPr>
+              <a:t>Titel</a:t>
+            </a:r>
+            <a:endParaRPr lang="en-US" dirty="0"/>
+          </a:p>
+        </p:txBody>
+      </p:sp>
+      <p:sp>
+        <p:nvSpPr>
+          <p:cNvPr id="3" name="Body 3-3"/>
+          <p:cNvSpPr/>
+          <p:nvPr>
+            <p:ph idx="101" type="body" hasCustomPrompt="1"/>
+          </p:nvPr>
+        </p:nvSpPr>
+        <p:spPr>
+          <a:xfrm>
+            <a:off x="640080" y="1645920"/>
+            <a:ext cx="10972800" cy="4572000"/>
+          </a:xfrm>
+          <a:prstGeom prst="rect">
+            <a:avLst/>
+          </a:prstGeom>
+          <a:noFill/>
+          <a:ln/>
+        </p:spPr>
+        <p:txBody>
+          <a:bodyPr wrap="square" rtlCol="0"/>
+          <a:lstStyle>
+            <a:lvl1pPr indent="0" marL="0">
+              <a:buNone/>
+              <a:defRPr lang="en-US" dirty="0"/>
+            </a:lvl1pPr>
+          </a:lstStyle>
+          <a:p>
+            <a:pPr indent="0" marL="0">
+              <a:buNone/>
+            </a:pPr>
+            <a:r>
+              <a:rPr lang="en-US" dirty="0">
+                <a:solidFill>
+                  <a:srgbClr val="000000"/>
+                </a:solidFill>
+              </a:rPr>
+              <a:t>Inhalt</a:t>
+            </a:r>
+            <a:endParaRPr lang="en-US" dirty="0"/>
+          </a:p>
+        </p:txBody>
+      </p:sp>
+    </p:spTree>
+  </p:cSld>
+  <p:clrMapOvr>
+    <a:masterClrMapping/>
+  </p:clrMapOvr>
+</p:sldLayout>
+</file>
+
+<file path=ppt/slideLayouts/slideLayout4.xml><?xml version="1.0" encoding="utf-8"?>
+<p:sldLayout xmlns:a="http://schemas.openxmlformats.org/drawingml/2006/main" xmlns:r="http://schemas.openxmlformats.org/officeDocument/2006/relationships" xmlns:p="http://schemas.openxmlformats.org/presentationml/2006/main" preserve="1">
+  <p:cSld name="TWO_COLUMN">
+    <p:bg>
+      <p:bgPr>
+        <a:solidFill>
+          <a:srgbClr val="FFFFFF"/>
+        </a:solidFill>
+      </p:bgPr>
+    </p:bg>
+    <p:spTree>
+      <p:nvGrpSpPr>
+        <p:cNvPr id="1" name="Ph 4-1"/>
+        <p:cNvGrpSpPr/>
+        <p:nvPr/>
+      </p:nvGrpSpPr>
+      <p:grpSpPr>
+        <a:xfrm>
+          <a:off x="0" y="0"/>
+          <a:ext cx="0" cy="0"/>
+          <a:chOff x="0" y="0"/>
+          <a:chExt cx="0" cy="0"/>
+        </a:xfrm>
+      </p:grpSpPr>
+      <p:sp>
+        <p:nvSpPr>
+          <p:cNvPr id="2" name="Ph 4-2"/>
+          <p:cNvSpPr/>
+          <p:nvPr>
+            <p:ph idx="100" type="title" hasCustomPrompt="1"/>
+          </p:nvPr>
+        </p:nvSpPr>
+        <p:spPr>
+          <a:xfrm>
+            <a:off x="640080" y="365760"/>
+            <a:ext cx="10972800" cy="914400"/>
+          </a:xfrm>
+          <a:prstGeom prst="rect">
+            <a:avLst/>
+          </a:prstGeom>
+          <a:noFill/>
+          <a:ln/>
+        </p:spPr>
+        <p:txBody>
+          <a:bodyPr wrap="square" rtlCol="0"/>
+          <a:lstStyle>
+            <a:lvl1pPr indent="0" marL="0">
+              <a:buNone/>
+              <a:defRPr lang="en-US" dirty="0"/>
+            </a:lvl1pPr>
+          </a:lstStyle>
+          <a:p>
+            <a:pPr indent="0" marL="0">
+              <a:buNone/>
+            </a:pPr>
+            <a:r>
+              <a:rPr lang="en-US" dirty="0">
+                <a:solidFill>
+                  <a:srgbClr val="000000"/>
+                </a:solidFill>
+              </a:rPr>
+              <a:t>Titel</a:t>
+            </a:r>
+            <a:endParaRPr lang="en-US" dirty="0"/>
+          </a:p>
+        </p:txBody>
+      </p:sp>
+      <p:sp>
+        <p:nvSpPr>
+          <p:cNvPr id="3" name="Ph 4-3"/>
+          <p:cNvSpPr/>
+          <p:nvPr>
+            <p:ph idx="101" type="body" hasCustomPrompt="1"/>
+          </p:nvPr>
+        </p:nvSpPr>
+        <p:spPr>
+          <a:xfrm>
+            <a:off x="640080" y="1645920"/>
+            <a:ext cx="5303520" cy="4572000"/>
+          </a:xfrm>
+          <a:prstGeom prst="rect">
+            <a:avLst/>
+          </a:prstGeom>
+          <a:noFill/>
+          <a:ln/>
+        </p:spPr>
+        <p:txBody>
+          <a:bodyPr wrap="square" rtlCol="0"/>
+          <a:lstStyle>
+            <a:lvl1pPr indent="0" marL="0">
+              <a:buNone/>
+              <a:defRPr lang="en-US" dirty="0"/>
+            </a:lvl1pPr>
+          </a:lstStyle>
+          <a:p>
+            <a:pPr indent="0" marL="0">
+              <a:buNone/>
+            </a:pPr>
+            <a:r>
+              <a:rPr lang="en-US" dirty="0">
+                <a:solidFill>
+                  <a:srgbClr val="000000"/>
+                </a:solidFill>
+              </a:rPr>
+              <a:t>Links</a:t>
+            </a:r>
+            <a:endParaRPr lang="en-US" dirty="0"/>
+          </a:p>
+        </p:txBody>
+      </p:sp>
+      <p:sp>
+        <p:nvSpPr>
+          <p:cNvPr id="4" name="Ph 4-4"/>
+          <p:cNvSpPr/>
+          <p:nvPr>
+            <p:ph idx="102" type="body" hasCustomPrompt="1"/>
+          </p:nvPr>
+        </p:nvSpPr>
+        <p:spPr>
+          <a:xfrm>
+            <a:off x="6309360" y="1645920"/>
+            <a:ext cx="5303520" cy="4572000"/>
+          </a:xfrm>
+          <a:prstGeom prst="rect">
+            <a:avLst/>
+          </a:prstGeom>
+          <a:noFill/>
+          <a:ln/>
+        </p:spPr>
+        <p:txBody>
+          <a:bodyPr wrap="square" rtlCol="0"/>
+          <a:lstStyle>
+            <a:lvl1pPr indent="0" marL="0">
+              <a:buNone/>
+              <a:defRPr lang="en-US" dirty="0"/>
+            </a:lvl1pPr>
+          </a:lstStyle>
+          <a:p>
+            <a:pPr indent="0" marL="0">
+              <a:buNone/>
+            </a:pPr>
+            <a:r>
+              <a:rPr lang="en-US" dirty="0">
+                <a:solidFill>
+                  <a:srgbClr val="000000"/>
+                </a:solidFill>
+              </a:rPr>
+              <a:t>Rechts</a:t>
+            </a:r>
+            <a:endParaRPr lang="en-US" dirty="0"/>
+          </a:p>
+        </p:txBody>
+      </p:sp>
+    </p:spTree>
+  </p:cSld>
+  <p:clrMapOvr>
+    <a:masterClrMapping/>
+  </p:clrMapOvr>
+</p:sldLayout>
+</file>
+
+<file path=ppt/slideLayouts/slideLayout5.xml><?xml version="1.0" encoding="utf-8"?>
+<p:sldLayout xmlns:a="http://schemas.openxmlformats.org/drawingml/2006/main" xmlns:r="http://schemas.openxmlformats.org/officeDocument/2006/relationships" xmlns:p="http://schemas.openxmlformats.org/presentationml/2006/main" type="pic" preserve="1">
+  <p:cSld name="PICTURE">
     <p:spTree>
       <p:nvGrpSpPr>
         <p:cNvPr id="1" name=""/>
@@ -896,10 +1168,12 @@
       </p:grpSpPr>
       <p:sp>
         <p:nvSpPr>
-          <p:cNvPr id="2" name="Text 0"/>
-          <p:cNvSpPr/>
-          <p:nvPr>
-            <p:ph idx="100" type="title" hasCustomPrompt="1"/>
+          <p:cNvPr id="2" name="Title"/>
+          <p:cNvSpPr>
+            <a:spLocks noGrp="1"/>
+          </p:cNvSpPr>
+          <p:nvPr>
+            <p:ph type="title" idx="100" hasCustomPrompt="1"/>
           </p:nvPr>
         </p:nvSpPr>
         <p:spPr>
@@ -910,234 +1184,39 @@
           <a:prstGeom prst="rect">
             <a:avLst/>
           </a:prstGeom>
-          <a:noFill/>
-          <a:ln/>
-        </p:spPr>
-        <p:txBody>
-          <a:bodyPr wrap="square" rtlCol="0"/>
-          <a:lstStyle>
-            <a:lvl1pPr indent="0" marL="0">
-              <a:buNone/>
-              <a:defRPr lang="en-US" dirty="0"/>
-            </a:lvl1pPr>
-          </a:lstStyle>
-          <a:p>
-            <a:pPr indent="0" marL="0">
-              <a:buNone/>
-            </a:pPr>
-            <a:r>
-              <a:rPr lang="en-US" dirty="0">
-                <a:solidFill>
-                  <a:srgbClr val="000000"/>
-                </a:solidFill>
-              </a:rPr>
-              <a:t>Titel</a:t>
-            </a:r>
-            <a:endParaRPr lang="en-US" dirty="0"/>
-          </a:p>
-        </p:txBody>
-      </p:sp>
-      <p:sp>
-        <p:nvSpPr>
-          <p:cNvPr id="3" name="Text 0"/>
-          <p:cNvSpPr/>
-          <p:nvPr>
-            <p:ph idx="101" type="body" hasCustomPrompt="1"/>
+        </p:spPr>
+        <p:txBody>
+          <a:bodyPr/>
+          <a:lstStyle/>
+          <a:p>
+            <a:endParaRPr/>
+          </a:p>
+        </p:txBody>
+      </p:sp>
+      <p:sp>
+        <p:nvSpPr>
+          <p:cNvPr id="3" name="Picture"/>
+          <p:cNvSpPr>
+            <a:spLocks noGrp="1"/>
+          </p:cNvSpPr>
+          <p:nvPr>
+            <p:ph type="pic" idx="103"/>
           </p:nvPr>
         </p:nvSpPr>
         <p:spPr>
           <a:xfrm>
             <a:off x="640080" y="1645920"/>
-            <a:ext cx="10972800" cy="4572000"/>
-          </a:xfrm>
-          <a:prstGeom prst="rect">
-            <a:avLst/>
-          </a:prstGeom>
-          <a:noFill/>
-          <a:ln/>
-        </p:spPr>
-        <p:txBody>
-          <a:bodyPr wrap="square" rtlCol="0"/>
-          <a:lstStyle>
-            <a:lvl1pPr indent="0" marL="0">
-              <a:buNone/>
-              <a:defRPr lang="en-US" dirty="0"/>
-            </a:lvl1pPr>
-          </a:lstStyle>
-          <a:p>
-            <a:pPr indent="0" marL="0">
-              <a:buNone/>
-            </a:pPr>
-            <a:r>
-              <a:rPr lang="en-US" dirty="0">
-                <a:solidFill>
-                  <a:srgbClr val="000000"/>
-                </a:solidFill>
-              </a:rPr>
-              <a:t>Inhalt</a:t>
-            </a:r>
-            <a:endParaRPr lang="en-US" dirty="0"/>
-          </a:p>
-        </p:txBody>
-      </p:sp>
-    </p:spTree>
-  </p:cSld>
-  <p:clrMapOvr>
-    <a:masterClrMapping/>
-  </p:clrMapOvr>
-</p:sldLayout>
-</file>
-
-<file path=ppt/slideLayouts/slideLayout4.xml><?xml version="1.0" encoding="utf-8"?>
-<p:sldLayout xmlns:a="http://schemas.openxmlformats.org/drawingml/2006/main" xmlns:r="http://schemas.openxmlformats.org/officeDocument/2006/relationships" xmlns:p="http://schemas.openxmlformats.org/presentationml/2006/main" preserve="1">
-  <p:cSld name="TWO_COLUMN">
-    <p:bg>
-      <p:bgPr>
-        <a:solidFill>
-          <a:srgbClr val="FFFFFF"/>
-        </a:solidFill>
-      </p:bgPr>
-    </p:bg>
-    <p:spTree>
-      <p:nvGrpSpPr>
-        <p:cNvPr id="1" name=""/>
-        <p:cNvGrpSpPr/>
-        <p:nvPr/>
-      </p:nvGrpSpPr>
-      <p:grpSpPr>
-        <a:xfrm>
-          <a:off x="0" y="0"/>
-          <a:ext cx="0" cy="0"/>
-          <a:chOff x="0" y="0"/>
-          <a:chExt cx="0" cy="0"/>
-        </a:xfrm>
-      </p:grpSpPr>
-      <p:sp>
-        <p:nvSpPr>
-          <p:cNvPr id="2" name="Text 0"/>
-          <p:cNvSpPr/>
-          <p:nvPr>
-            <p:ph idx="100" type="title" hasCustomPrompt="1"/>
-          </p:nvPr>
-        </p:nvSpPr>
-        <p:spPr>
-          <a:xfrm>
-            <a:off x="640080" y="365760"/>
-            <a:ext cx="10972800" cy="914400"/>
-          </a:xfrm>
-          <a:prstGeom prst="rect">
-            <a:avLst/>
-          </a:prstGeom>
-          <a:noFill/>
-          <a:ln/>
-        </p:spPr>
-        <p:txBody>
-          <a:bodyPr wrap="square" rtlCol="0"/>
-          <a:lstStyle>
-            <a:lvl1pPr indent="0" marL="0">
-              <a:buNone/>
-              <a:defRPr lang="en-US" dirty="0"/>
-            </a:lvl1pPr>
-          </a:lstStyle>
-          <a:p>
-            <a:pPr indent="0" marL="0">
-              <a:buNone/>
-            </a:pPr>
-            <a:r>
-              <a:rPr lang="en-US" dirty="0">
-                <a:solidFill>
-                  <a:srgbClr val="000000"/>
-                </a:solidFill>
-              </a:rPr>
-              <a:t>Titel</a:t>
-            </a:r>
-            <a:endParaRPr lang="en-US" dirty="0"/>
-          </a:p>
-        </p:txBody>
-      </p:sp>
-      <p:sp>
-        <p:nvSpPr>
-          <p:cNvPr id="3" name="Text 0"/>
-          <p:cNvSpPr/>
-          <p:nvPr>
-            <p:ph idx="101" type="body" hasCustomPrompt="1"/>
-          </p:nvPr>
-        </p:nvSpPr>
-        <p:spPr>
-          <a:xfrm>
-            <a:off x="640080" y="1645920"/>
-            <a:ext cx="5303520" cy="4572000"/>
-          </a:xfrm>
-          <a:prstGeom prst="rect">
-            <a:avLst/>
-          </a:prstGeom>
-          <a:noFill/>
-          <a:ln/>
-        </p:spPr>
-        <p:txBody>
-          <a:bodyPr wrap="square" rtlCol="0"/>
-          <a:lstStyle>
-            <a:lvl1pPr indent="0" marL="0">
-              <a:buNone/>
-              <a:defRPr lang="en-US" dirty="0"/>
-            </a:lvl1pPr>
-          </a:lstStyle>
-          <a:p>
-            <a:pPr indent="0" marL="0">
-              <a:buNone/>
-            </a:pPr>
-            <a:r>
-              <a:rPr lang="en-US" dirty="0">
-                <a:solidFill>
-                  <a:srgbClr val="000000"/>
-                </a:solidFill>
-              </a:rPr>
-              <a:t>Links</a:t>
-            </a:r>
-            <a:endParaRPr lang="en-US" dirty="0"/>
-          </a:p>
-        </p:txBody>
-      </p:sp>
-      <p:sp>
-        <p:nvSpPr>
-          <p:cNvPr id="4" name="Text 0"/>
-          <p:cNvSpPr/>
-          <p:nvPr>
-            <p:ph idx="102" type="body" hasCustomPrompt="1"/>
-          </p:nvPr>
-        </p:nvSpPr>
-        <p:spPr>
-          <a:xfrm>
-            <a:off x="6309360" y="1645920"/>
-            <a:ext cx="5303520" cy="4572000"/>
-          </a:xfrm>
-          <a:prstGeom prst="rect">
-            <a:avLst/>
-          </a:prstGeom>
-          <a:noFill/>
-          <a:ln/>
-        </p:spPr>
-        <p:txBody>
-          <a:bodyPr wrap="square" rtlCol="0"/>
-          <a:lstStyle>
-            <a:lvl1pPr indent="0" marL="0">
-              <a:buNone/>
-              <a:defRPr lang="en-US" dirty="0"/>
-            </a:lvl1pPr>
-          </a:lstStyle>
-          <a:p>
-            <a:pPr indent="0" marL="0">
-              <a:buNone/>
-            </a:pPr>
-            <a:r>
-              <a:rPr lang="en-US" dirty="0">
-                <a:solidFill>
-                  <a:srgbClr val="000000"/>
-                </a:solidFill>
-              </a:rPr>
-              <a:t>Rechts</a:t>
-            </a:r>
-            <a:endParaRPr lang="en-US" dirty="0"/>
+            <a:ext cx="6400800" cy="4572000"/>
+          </a:xfrm>
+          <a:prstGeom prst="rect">
+            <a:avLst/>
+          </a:prstGeom>
+        </p:spPr>
+        <p:txBody>
+          <a:bodyPr/>
+          <a:lstStyle/>
+          <a:p>
+            <a:endParaRPr/>
           </a:p>
         </p:txBody>
       </p:sp>
@@ -1174,6 +1253,7 @@
     <p:sldLayoutId id="2147483650" r:id="rId2"/>
     <p:sldLayoutId id="2147483651" r:id="rId3"/>
     <p:sldLayoutId id="2147483652" r:id="rId4"/>
+    <p:sldLayoutId id="2147483653" r:id="rId6"/>
   </p:sldLayoutIdLst>
   <p:hf sldNum="0" hdr="0" ftr="0" dt="0"/>
   <p:txStyles>

</xml_diff>

<commit_message>
0.2.3: presentation element order and chart/media garbage collection
Two more PowerPoint repair triggers, found by opening the stress and
fuzz artifacts:

- CT_Presentation is an ordered sequence: notesMasterIdLst and
  handoutMasterIdLst must precede sldIdLst. The seed builder now
  normalizes the order (the synthetic fixture violated it, so EVERY
  fixture-derived deck prompted a repair).
- automizer duplicates chart parts and accumulates stale slide
  relationships on every re-apply (1 chart -> 64 across 6 applies):
  prune slide rels whose id no longer occurs in the slide XML, then
  GC charts/embeddings/media unreachable from any live part. Also
  closes the documented media-of-removed-slides limitation.
- integrity validator: checks for presentation element order and
  orphan assets; stress suite asserts exactly one chart survives.

Co-Authored-By: Claude Fable 5 <noreply@anthropic.com>
</commit_message>
<xml_diff>
--- a/test/fixtures/neutral-template.pptx
+++ b/test/fixtures/neutral-template.pptx
@@ -4,14 +4,14 @@
   <p:sldMasterIdLst>
     <p:sldMasterId id="2147483648" r:id="rId1"/>
   </p:sldMasterIdLst>
+  <p:notesMasterIdLst>
+    <p:notesMasterId r:id="rId5"/>
+  </p:notesMasterIdLst>
   <p:sldIdLst>
     <p:sldId id="256" r:id="rId2"/>
     <p:sldId id="257" r:id="rId3"/>
     <p:sldId id="258" r:id="rId4"/>
   </p:sldIdLst>
-  <p:notesMasterIdLst>
-    <p:notesMasterId r:id="rId5"/>
-  </p:notesMasterIdLst>
   <p:sldSz cx="12188952" cy="6858000"/>
   <p:notesSz cx="6858000" cy="12188952"/>
   <p:defaultTextStyle>

</xml_diff>